<commit_message>
docs: update SIH official deck PPTX and Speech PDF for Team DELTA with verified sensor physics and storytelling speech
</commit_message>
<xml_diff>
--- a/SIH2026_AURA_Official_Template_Deck.pptx
+++ b/SIH2026_AURA_Official_Template_Deck.pptx
@@ -3123,7 +3123,7 @@
               </a:defRPr>
             </a:pPr>
             <a:r>
-              <a:t>[LOGO] [ Team AntiGravity ]</a:t>
+              <a:t>[LOGO] [ Team DELTA ]</a:t>
             </a:r>
           </a:p>
         </p:txBody>
@@ -3275,7 +3275,7 @@
               </a:defRPr>
             </a:pPr>
             <a:r>
-              <a:t>SIH 2026 — Idea Submission — [ Project A.U.R.A. / Team AntiGravity ]</a:t>
+              <a:t>SIH 2026 — Idea Submission — [ Project A.U.R.A. / Team DELTA ]</a:t>
             </a:r>
           </a:p>
         </p:txBody>
@@ -3462,7 +3462,7 @@
                   <a:srgbClr val="1B365D"/>
                 </a:solidFill>
               </a:rPr>
-              <a:t>[ Team AntiGravity ]
+              <a:t>[ Team DELTA ]
 </a:t>
             </a:r>
           </a:p>
@@ -3481,7 +3481,7 @@
                   <a:srgbClr val="1B365D"/>
                 </a:solidFill>
               </a:rPr>
-              <a:t>[ T2026-AURA ]
+              <a:t>[ T2026-DELTA ]
 </a:t>
             </a:r>
           </a:p>
@@ -3646,7 +3646,7 @@
               </a:defRPr>
             </a:pPr>
             <a:r>
-              <a:t>[LOGO] [ Team AntiGravity ]</a:t>
+              <a:t>[LOGO] [ Team DELTA ]</a:t>
             </a:r>
           </a:p>
         </p:txBody>
@@ -3798,7 +3798,7 @@
               </a:defRPr>
             </a:pPr>
             <a:r>
-              <a:t>SIH 2026 — Idea Submission — [ Project A.U.R.A. / Team AntiGravity ]</a:t>
+              <a:t>SIH 2026 — Idea Submission — [ Project A.U.R.A. / Team DELTA ]</a:t>
             </a:r>
           </a:p>
         </p:txBody>
@@ -5047,7 +5047,7 @@
               </a:defRPr>
             </a:pPr>
             <a:r>
-              <a:t>[LOGO] [ Team AntiGravity ]</a:t>
+              <a:t>[LOGO] [ Team DELTA ]</a:t>
             </a:r>
           </a:p>
         </p:txBody>
@@ -5199,7 +5199,7 @@
               </a:defRPr>
             </a:pPr>
             <a:r>
-              <a:t>SIH 2026 — Idea Submission — [ Project A.U.R.A. / Team AntiGravity ]</a:t>
+              <a:t>SIH 2026 — Idea Submission — [ Project A.U.R.A. / Team DELTA ]</a:t>
             </a:r>
           </a:p>
         </p:txBody>
@@ -6352,7 +6352,7 @@
               </a:defRPr>
             </a:pPr>
             <a:r>
-              <a:t>[LOGO] [ Team AntiGravity ]</a:t>
+              <a:t>[LOGO] [ Team DELTA ]</a:t>
             </a:r>
           </a:p>
         </p:txBody>
@@ -6504,7 +6504,7 @@
               </a:defRPr>
             </a:pPr>
             <a:r>
-              <a:t>SIH 2026 — Idea Submission — [ Project A.U.R.A. / Team AntiGravity ]</a:t>
+              <a:t>SIH 2026 — Idea Submission — [ Project A.U.R.A. / Team DELTA ]</a:t>
             </a:r>
           </a:p>
         </p:txBody>
@@ -7696,7 +7696,7 @@
               </a:defRPr>
             </a:pPr>
             <a:r>
-              <a:t>[LOGO] [ Team AntiGravity ]</a:t>
+              <a:t>[LOGO] [ Team DELTA ]</a:t>
             </a:r>
           </a:p>
         </p:txBody>
@@ -7848,7 +7848,7 @@
               </a:defRPr>
             </a:pPr>
             <a:r>
-              <a:t>SIH 2026 — Idea Submission — [ Project A.U.R.A. / Team AntiGravity ]</a:t>
+              <a:t>SIH 2026 — Idea Submission — [ Project A.U.R.A. / Team DELTA ]</a:t>
             </a:r>
           </a:p>
         </p:txBody>
@@ -8695,7 +8695,7 @@
               </a:defRPr>
             </a:pPr>
             <a:r>
-              <a:t>[LOGO] [ Team AntiGravity ]</a:t>
+              <a:t>[LOGO] [ Team DELTA ]</a:t>
             </a:r>
           </a:p>
         </p:txBody>
@@ -8730,7 +8730,7 @@
               </a:defRPr>
             </a:pPr>
             <a:r>
-              <a:t>TEAM ANTIGRAVITY &amp; LIVE DEMO</a:t>
+              <a:t>TEAM DELTA &amp; LIVE DEMO</a:t>
             </a:r>
           </a:p>
         </p:txBody>
@@ -8847,7 +8847,7 @@
               </a:defRPr>
             </a:pPr>
             <a:r>
-              <a:t>SIH 2026 — Idea Submission — [ Project A.U.R.A. / Team AntiGravity ]</a:t>
+              <a:t>SIH 2026 — Idea Submission — [ Project A.U.R.A. / Team DELTA ]</a:t>
             </a:r>
           </a:p>
         </p:txBody>

</xml_diff>